<commit_message>
Quartz sync: Jul 27, 2025, 3:34 PM
</commit_message>
<xml_diff>
--- a/content/Articles/session34-35tokens.pptx
+++ b/content/Articles/session34-35tokens.pptx
@@ -7,7 +7,9 @@
   <p:sldIdLst>
     <p:sldId id="270" r:id="rId2"/>
     <p:sldId id="272" r:id="rId3"/>
-    <p:sldId id="273" r:id="rId4"/>
+    <p:sldId id="274" r:id="rId4"/>
+    <p:sldId id="275" r:id="rId5"/>
+    <p:sldId id="273" r:id="rId6"/>
   </p:sldIdLst>
   <p:sldSz cx="7772400" cy="10058400"/>
   <p:notesSz cx="7315200" cy="9601200"/>
@@ -117,8 +119,7 @@
 <file path=ppt/revisionInfo.xml><?xml version="1.0" encoding="utf-8"?>
 <p1510:revInfo xmlns:a="http://schemas.openxmlformats.org/drawingml/2006/main" xmlns:r="http://schemas.openxmlformats.org/officeDocument/2006/relationships" xmlns:p1510="http://schemas.microsoft.com/office/powerpoint/2015/10/main">
   <p1510:revLst>
-    <p1510:client id="{292AD870-3EF4-4941-847D-EA3A6F1D2663}" v="163" dt="2025-07-15T02:49:18.810"/>
-    <p1510:client id="{435F300D-6CAF-4321-8599-B61F303F931A}" v="5" dt="2025-07-15T02:28:43.037"/>
+    <p1510:client id="{292AD870-3EF4-4941-847D-EA3A6F1D2663}" v="246" dt="2025-07-27T17:32:23.779"/>
   </p1510:revLst>
 </p1510:revInfo>
 </file>
@@ -145,22 +146,6 @@
           <pc:docMk/>
           <pc:sldMk cId="2296457534" sldId="269"/>
         </pc:sldMkLst>
-        <pc:picChg chg="add mod">
-          <ac:chgData name="Jack Bond" userId="d0613b4d9d68792d" providerId="LiveId" clId="{435F300D-6CAF-4321-8599-B61F303F931A}" dt="2025-07-15T02:26:10.826" v="11" actId="1076"/>
-          <ac:picMkLst>
-            <pc:docMk/>
-            <pc:sldMk cId="2296457534" sldId="269"/>
-            <ac:picMk id="3" creationId="{E672A2A6-FF31-AF9C-8F7A-563C23F7CD6E}"/>
-          </ac:picMkLst>
-        </pc:picChg>
-        <pc:picChg chg="add mod">
-          <ac:chgData name="Jack Bond" userId="d0613b4d9d68792d" providerId="LiveId" clId="{435F300D-6CAF-4321-8599-B61F303F931A}" dt="2025-07-15T02:27:46.262" v="56" actId="1076"/>
-          <ac:picMkLst>
-            <pc:docMk/>
-            <pc:sldMk cId="2296457534" sldId="269"/>
-            <ac:picMk id="5" creationId="{21E85C9E-F959-A57E-9AE1-CA9110DF062E}"/>
-          </ac:picMkLst>
-        </pc:picChg>
       </pc:sldChg>
       <pc:sldChg chg="add">
         <pc:chgData name="Jack Bond" userId="d0613b4d9d68792d" providerId="LiveId" clId="{435F300D-6CAF-4321-8599-B61F303F931A}" dt="2025-07-15T02:28:43.037" v="64"/>
@@ -175,22 +160,6 @@
           <pc:docMk/>
           <pc:sldMk cId="3485330045" sldId="270"/>
         </pc:sldMkLst>
-        <pc:picChg chg="add mod">
-          <ac:chgData name="Jack Bond" userId="d0613b4d9d68792d" providerId="LiveId" clId="{435F300D-6CAF-4321-8599-B61F303F931A}" dt="2025-07-15T02:26:50.357" v="30" actId="1076"/>
-          <ac:picMkLst>
-            <pc:docMk/>
-            <pc:sldMk cId="3485330045" sldId="270"/>
-            <ac:picMk id="3" creationId="{F36EB111-C606-4078-3B4B-864CC8F25446}"/>
-          </ac:picMkLst>
-        </pc:picChg>
-        <pc:picChg chg="add mod">
-          <ac:chgData name="Jack Bond" userId="d0613b4d9d68792d" providerId="LiveId" clId="{435F300D-6CAF-4321-8599-B61F303F931A}" dt="2025-07-15T02:26:48.476" v="29" actId="1076"/>
-          <ac:picMkLst>
-            <pc:docMk/>
-            <pc:sldMk cId="3485330045" sldId="270"/>
-            <ac:picMk id="5" creationId="{0DA55B62-3D38-ECF5-9286-F231F1A96BEC}"/>
-          </ac:picMkLst>
-        </pc:picChg>
       </pc:sldChg>
       <pc:sldChg chg="addSp modSp new mod ord">
         <pc:chgData name="Jack Bond" userId="d0613b4d9d68792d" providerId="LiveId" clId="{435F300D-6CAF-4321-8599-B61F303F931A}" dt="2025-07-15T02:28:34.772" v="62"/>
@@ -198,14 +167,6 @@
           <pc:docMk/>
           <pc:sldMk cId="2868086417" sldId="271"/>
         </pc:sldMkLst>
-        <pc:picChg chg="add mod">
-          <ac:chgData name="Jack Bond" userId="d0613b4d9d68792d" providerId="LiveId" clId="{435F300D-6CAF-4321-8599-B61F303F931A}" dt="2025-07-15T02:28:02.061" v="60" actId="1076"/>
-          <ac:picMkLst>
-            <pc:docMk/>
-            <pc:sldMk cId="2868086417" sldId="271"/>
-            <ac:picMk id="3" creationId="{047470EB-E472-ED2F-C8AE-9C4AC61FC020}"/>
-          </ac:picMkLst>
-        </pc:picChg>
       </pc:sldChg>
       <pc:sldChg chg="addSp delSp modSp new del mod">
         <pc:chgData name="Jack Bond" userId="d0613b4d9d68792d" providerId="LiveId" clId="{435F300D-6CAF-4321-8599-B61F303F931A}" dt="2025-07-15T02:28:37.920" v="63" actId="2696"/>
@@ -213,30 +174,6 @@
           <pc:docMk/>
           <pc:sldMk cId="2730225920" sldId="272"/>
         </pc:sldMkLst>
-        <pc:picChg chg="add mod">
-          <ac:chgData name="Jack Bond" userId="d0613b4d9d68792d" providerId="LiveId" clId="{435F300D-6CAF-4321-8599-B61F303F931A}" dt="2025-07-15T02:27:34.616" v="54" actId="1076"/>
-          <ac:picMkLst>
-            <pc:docMk/>
-            <pc:sldMk cId="2730225920" sldId="272"/>
-            <ac:picMk id="3" creationId="{BBB8FF5C-F60A-F0B7-5363-23C3CF7C4F19}"/>
-          </ac:picMkLst>
-        </pc:picChg>
-        <pc:picChg chg="add mod">
-          <ac:chgData name="Jack Bond" userId="d0613b4d9d68792d" providerId="LiveId" clId="{435F300D-6CAF-4321-8599-B61F303F931A}" dt="2025-07-15T02:27:32.497" v="53" actId="1076"/>
-          <ac:picMkLst>
-            <pc:docMk/>
-            <pc:sldMk cId="2730225920" sldId="272"/>
-            <ac:picMk id="5" creationId="{6E91576D-A001-42CC-FAAE-9319EE21BD0A}"/>
-          </ac:picMkLst>
-        </pc:picChg>
-        <pc:picChg chg="add del mod">
-          <ac:chgData name="Jack Bond" userId="d0613b4d9d68792d" providerId="LiveId" clId="{435F300D-6CAF-4321-8599-B61F303F931A}" dt="2025-07-15T02:27:24.411" v="49" actId="478"/>
-          <ac:picMkLst>
-            <pc:docMk/>
-            <pc:sldMk cId="2730225920" sldId="272"/>
-            <ac:picMk id="7" creationId="{292A75B9-7688-B210-8862-A35A44374C68}"/>
-          </ac:picMkLst>
-        </pc:picChg>
       </pc:sldChg>
       <pc:sldChg chg="add">
         <pc:chgData name="Jack Bond" userId="d0613b4d9d68792d" providerId="LiveId" clId="{435F300D-6CAF-4321-8599-B61F303F931A}" dt="2025-07-15T02:28:43.037" v="64"/>
@@ -314,8 +251,8 @@
   </pc:docChgLst>
   <pc:docChgLst>
     <pc:chgData name="Jack Bond" userId="d0613b4d9d68792d" providerId="LiveId" clId="{292AD870-3EF4-4941-847D-EA3A6F1D2663}"/>
-    <pc:docChg chg="addSld delSld modSld">
-      <pc:chgData name="Jack Bond" userId="d0613b4d9d68792d" providerId="LiveId" clId="{292AD870-3EF4-4941-847D-EA3A6F1D2663}" dt="2025-07-15T02:49:18.808" v="164" actId="1076"/>
+    <pc:docChg chg="undo custSel addSld delSld modSld">
+      <pc:chgData name="Jack Bond" userId="d0613b4d9d68792d" providerId="LiveId" clId="{292AD870-3EF4-4941-847D-EA3A6F1D2663}" dt="2025-07-27T17:32:57.461" v="372" actId="1035"/>
       <pc:docMkLst>
         <pc:docMk/>
       </pc:docMkLst>
@@ -326,6 +263,29 @@
           <pc:sldMk cId="2296457534" sldId="269"/>
         </pc:sldMkLst>
       </pc:sldChg>
+      <pc:sldChg chg="modSp mod">
+        <pc:chgData name="Jack Bond" userId="d0613b4d9d68792d" providerId="LiveId" clId="{292AD870-3EF4-4941-847D-EA3A6F1D2663}" dt="2025-07-27T17:32:57.461" v="372" actId="1035"/>
+        <pc:sldMkLst>
+          <pc:docMk/>
+          <pc:sldMk cId="1470260589" sldId="270"/>
+        </pc:sldMkLst>
+        <pc:picChg chg="mod">
+          <ac:chgData name="Jack Bond" userId="d0613b4d9d68792d" providerId="LiveId" clId="{292AD870-3EF4-4941-847D-EA3A6F1D2663}" dt="2025-07-27T17:32:57.461" v="372" actId="1035"/>
+          <ac:picMkLst>
+            <pc:docMk/>
+            <pc:sldMk cId="1470260589" sldId="270"/>
+            <ac:picMk id="3" creationId="{F36EB111-C606-4078-3B4B-864CC8F25446}"/>
+          </ac:picMkLst>
+        </pc:picChg>
+        <pc:picChg chg="mod">
+          <ac:chgData name="Jack Bond" userId="d0613b4d9d68792d" providerId="LiveId" clId="{292AD870-3EF4-4941-847D-EA3A6F1D2663}" dt="2025-07-27T17:32:23.778" v="327" actId="1367"/>
+          <ac:picMkLst>
+            <pc:docMk/>
+            <pc:sldMk cId="1470260589" sldId="270"/>
+            <ac:picMk id="5" creationId="{0DA55B62-3D38-ECF5-9286-F231F1A96BEC}"/>
+          </ac:picMkLst>
+        </pc:picChg>
+      </pc:sldChg>
       <pc:sldChg chg="del">
         <pc:chgData name="Jack Bond" userId="d0613b4d9d68792d" providerId="LiveId" clId="{292AD870-3EF4-4941-847D-EA3A6F1D2663}" dt="2025-07-15T02:29:25.372" v="0" actId="47"/>
         <pc:sldMkLst>
@@ -333,8 +293,39 @@
           <pc:sldMk cId="2868086417" sldId="271"/>
         </pc:sldMkLst>
       </pc:sldChg>
-      <pc:sldChg chg="addSp delSp modSp new">
-        <pc:chgData name="Jack Bond" userId="d0613b4d9d68792d" providerId="LiveId" clId="{292AD870-3EF4-4941-847D-EA3A6F1D2663}" dt="2025-07-15T02:49:18.808" v="164" actId="1076"/>
+      <pc:sldChg chg="addSp delSp modSp mod">
+        <pc:chgData name="Jack Bond" userId="d0613b4d9d68792d" providerId="LiveId" clId="{292AD870-3EF4-4941-847D-EA3A6F1D2663}" dt="2025-07-27T17:32:41.524" v="343" actId="1036"/>
+        <pc:sldMkLst>
+          <pc:docMk/>
+          <pc:sldMk cId="3751906151" sldId="272"/>
+        </pc:sldMkLst>
+        <pc:picChg chg="mod">
+          <ac:chgData name="Jack Bond" userId="d0613b4d9d68792d" providerId="LiveId" clId="{292AD870-3EF4-4941-847D-EA3A6F1D2663}" dt="2025-07-27T17:32:41.524" v="343" actId="1036"/>
+          <ac:picMkLst>
+            <pc:docMk/>
+            <pc:sldMk cId="3751906151" sldId="272"/>
+            <ac:picMk id="3" creationId="{BBB8FF5C-F60A-F0B7-5363-23C3CF7C4F19}"/>
+          </ac:picMkLst>
+        </pc:picChg>
+        <pc:picChg chg="add mod">
+          <ac:chgData name="Jack Bond" userId="d0613b4d9d68792d" providerId="LiveId" clId="{292AD870-3EF4-4941-847D-EA3A6F1D2663}" dt="2025-07-27T17:32:41.524" v="343" actId="1036"/>
+          <ac:picMkLst>
+            <pc:docMk/>
+            <pc:sldMk cId="3751906151" sldId="272"/>
+            <ac:picMk id="4" creationId="{733B8E86-7446-5332-023C-72FF8F909E1E}"/>
+          </ac:picMkLst>
+        </pc:picChg>
+        <pc:picChg chg="del">
+          <ac:chgData name="Jack Bond" userId="d0613b4d9d68792d" providerId="LiveId" clId="{292AD870-3EF4-4941-847D-EA3A6F1D2663}" dt="2025-07-27T17:26:09.523" v="228" actId="21"/>
+          <ac:picMkLst>
+            <pc:docMk/>
+            <pc:sldMk cId="3751906151" sldId="272"/>
+            <ac:picMk id="5" creationId="{6E91576D-A001-42CC-FAAE-9319EE21BD0A}"/>
+          </ac:picMkLst>
+        </pc:picChg>
+      </pc:sldChg>
+      <pc:sldChg chg="addSp delSp modSp new mod">
+        <pc:chgData name="Jack Bond" userId="d0613b4d9d68792d" providerId="LiveId" clId="{292AD870-3EF4-4941-847D-EA3A6F1D2663}" dt="2025-07-27T17:25:26.116" v="223" actId="1076"/>
         <pc:sldMkLst>
           <pc:docMk/>
           <pc:sldMk cId="1969434560" sldId="273"/>
@@ -364,11 +355,11 @@
           </ac:picMkLst>
         </pc:picChg>
         <pc:picChg chg="add del mod">
-          <ac:chgData name="Jack Bond" userId="d0613b4d9d68792d" providerId="LiveId" clId="{292AD870-3EF4-4941-847D-EA3A6F1D2663}" dt="2025-07-15T02:47:11.875" v="133" actId="478"/>
+          <ac:chgData name="Jack Bond" userId="d0613b4d9d68792d" providerId="LiveId" clId="{292AD870-3EF4-4941-847D-EA3A6F1D2663}" dt="2025-07-27T17:23:43.414" v="198" actId="21"/>
           <ac:picMkLst>
             <pc:docMk/>
             <pc:sldMk cId="1969434560" sldId="273"/>
-            <ac:picMk id="4" creationId="{83C9F192-528B-DCCC-0D23-C1C252D8F8C1}"/>
+            <ac:picMk id="4" creationId="{C8ED3A52-18C1-AA47-EF51-EEDBB00C0B6E}"/>
           </ac:picMkLst>
         </pc:picChg>
         <pc:picChg chg="add mod">
@@ -377,6 +368,54 @@
             <pc:docMk/>
             <pc:sldMk cId="1969434560" sldId="273"/>
             <ac:picMk id="5" creationId="{718F011A-43A6-2B64-977E-AA422A907BA1}"/>
+          </ac:picMkLst>
+        </pc:picChg>
+        <pc:picChg chg="add del mod">
+          <ac:chgData name="Jack Bond" userId="d0613b4d9d68792d" providerId="LiveId" clId="{292AD870-3EF4-4941-847D-EA3A6F1D2663}" dt="2025-07-27T17:25:11.974" v="217" actId="478"/>
+          <ac:picMkLst>
+            <pc:docMk/>
+            <pc:sldMk cId="1969434560" sldId="273"/>
+            <ac:picMk id="7" creationId="{C8ED3A52-18C1-AA47-EF51-EEDBB00C0B6E}"/>
+          </ac:picMkLst>
+        </pc:picChg>
+        <pc:picChg chg="add del mod">
+          <ac:chgData name="Jack Bond" userId="d0613b4d9d68792d" providerId="LiveId" clId="{292AD870-3EF4-4941-847D-EA3A6F1D2663}" dt="2025-07-27T17:25:16.348" v="220" actId="478"/>
+          <ac:picMkLst>
+            <pc:docMk/>
+            <pc:sldMk cId="1969434560" sldId="273"/>
+            <ac:picMk id="8" creationId="{01ABB497-9573-3A03-D6A2-C0A38528A167}"/>
+          </ac:picMkLst>
+        </pc:picChg>
+        <pc:picChg chg="add mod">
+          <ac:chgData name="Jack Bond" userId="d0613b4d9d68792d" providerId="LiveId" clId="{292AD870-3EF4-4941-847D-EA3A6F1D2663}" dt="2025-07-27T17:24:52.346" v="211" actId="1076"/>
+          <ac:picMkLst>
+            <pc:docMk/>
+            <pc:sldMk cId="1969434560" sldId="273"/>
+            <ac:picMk id="9" creationId="{95F1DAC2-36E2-BA82-E6F2-780B98055186}"/>
+          </ac:picMkLst>
+        </pc:picChg>
+        <pc:picChg chg="add mod">
+          <ac:chgData name="Jack Bond" userId="d0613b4d9d68792d" providerId="LiveId" clId="{292AD870-3EF4-4941-847D-EA3A6F1D2663}" dt="2025-07-27T17:24:56.399" v="213"/>
+          <ac:picMkLst>
+            <pc:docMk/>
+            <pc:sldMk cId="1969434560" sldId="273"/>
+            <ac:picMk id="10" creationId="{8729B43A-8CCE-DE2D-D4E0-89CA9F5351ED}"/>
+          </ac:picMkLst>
+        </pc:picChg>
+        <pc:picChg chg="add mod">
+          <ac:chgData name="Jack Bond" userId="d0613b4d9d68792d" providerId="LiveId" clId="{292AD870-3EF4-4941-847D-EA3A6F1D2663}" dt="2025-07-27T17:25:26.116" v="223" actId="1076"/>
+          <ac:picMkLst>
+            <pc:docMk/>
+            <pc:sldMk cId="1969434560" sldId="273"/>
+            <ac:picMk id="11" creationId="{1074A41F-3010-1D11-5AC9-95519D94BD92}"/>
+          </ac:picMkLst>
+        </pc:picChg>
+        <pc:picChg chg="add mod">
+          <ac:chgData name="Jack Bond" userId="d0613b4d9d68792d" providerId="LiveId" clId="{292AD870-3EF4-4941-847D-EA3A6F1D2663}" dt="2025-07-27T17:25:22.388" v="222" actId="1076"/>
+          <ac:picMkLst>
+            <pc:docMk/>
+            <pc:sldMk cId="1969434560" sldId="273"/>
+            <ac:picMk id="12" creationId="{15294488-E48F-F433-D3FB-734BDAE59C9C}"/>
           </ac:picMkLst>
         </pc:picChg>
         <pc:picChg chg="add mod">
@@ -393,6 +432,60 @@
             <pc:docMk/>
             <pc:sldMk cId="1969434560" sldId="273"/>
             <ac:picMk id="1028" creationId="{983E1986-F652-B44D-D07F-8E463ABF3276}"/>
+          </ac:picMkLst>
+        </pc:picChg>
+      </pc:sldChg>
+      <pc:sldChg chg="addSp delSp modSp new mod">
+        <pc:chgData name="Jack Bond" userId="d0613b4d9d68792d" providerId="LiveId" clId="{292AD870-3EF4-4941-847D-EA3A6F1D2663}" dt="2025-07-27T17:32:50.694" v="365" actId="1036"/>
+        <pc:sldMkLst>
+          <pc:docMk/>
+          <pc:sldMk cId="1481890868" sldId="274"/>
+        </pc:sldMkLst>
+        <pc:picChg chg="add mod">
+          <ac:chgData name="Jack Bond" userId="d0613b4d9d68792d" providerId="LiveId" clId="{292AD870-3EF4-4941-847D-EA3A6F1D2663}" dt="2025-07-27T17:32:50.694" v="365" actId="1036"/>
+          <ac:picMkLst>
+            <pc:docMk/>
+            <pc:sldMk cId="1481890868" sldId="274"/>
+            <ac:picMk id="3" creationId="{91AC78E9-A3D5-3A97-D22B-1C99083F134A}"/>
+          </ac:picMkLst>
+        </pc:picChg>
+        <pc:picChg chg="add del mod">
+          <ac:chgData name="Jack Bond" userId="d0613b4d9d68792d" providerId="LiveId" clId="{292AD870-3EF4-4941-847D-EA3A6F1D2663}" dt="2025-07-27T17:26:14.831" v="231" actId="21"/>
+          <ac:picMkLst>
+            <pc:docMk/>
+            <pc:sldMk cId="1481890868" sldId="274"/>
+            <ac:picMk id="5" creationId="{4B5CF763-5573-D89F-CCD4-E6AEBE44F4EA}"/>
+          </ac:picMkLst>
+        </pc:picChg>
+        <pc:picChg chg="add mod">
+          <ac:chgData name="Jack Bond" userId="d0613b4d9d68792d" providerId="LiveId" clId="{292AD870-3EF4-4941-847D-EA3A6F1D2663}" dt="2025-07-27T17:32:45.870" v="347" actId="1036"/>
+          <ac:picMkLst>
+            <pc:docMk/>
+            <pc:sldMk cId="1481890868" sldId="274"/>
+            <ac:picMk id="7" creationId="{8F7240C5-D356-1198-939E-F91B4DB0ACE6}"/>
+          </ac:picMkLst>
+        </pc:picChg>
+      </pc:sldChg>
+      <pc:sldChg chg="addSp modSp new mod">
+        <pc:chgData name="Jack Bond" userId="d0613b4d9d68792d" providerId="LiveId" clId="{292AD870-3EF4-4941-847D-EA3A6F1D2663}" dt="2025-07-27T17:31:18.924" v="313" actId="1367"/>
+        <pc:sldMkLst>
+          <pc:docMk/>
+          <pc:sldMk cId="3992297113" sldId="275"/>
+        </pc:sldMkLst>
+        <pc:picChg chg="add mod">
+          <ac:chgData name="Jack Bond" userId="d0613b4d9d68792d" providerId="LiveId" clId="{292AD870-3EF4-4941-847D-EA3A6F1D2663}" dt="2025-07-27T17:31:18.924" v="313" actId="1367"/>
+          <ac:picMkLst>
+            <pc:docMk/>
+            <pc:sldMk cId="3992297113" sldId="275"/>
+            <ac:picMk id="2" creationId="{4B5CF763-5573-D89F-CCD4-E6AEBE44F4EA}"/>
+          </ac:picMkLst>
+        </pc:picChg>
+        <pc:picChg chg="add mod">
+          <ac:chgData name="Jack Bond" userId="d0613b4d9d68792d" providerId="LiveId" clId="{292AD870-3EF4-4941-847D-EA3A6F1D2663}" dt="2025-07-27T17:31:02.501" v="309" actId="1035"/>
+          <ac:picMkLst>
+            <pc:docMk/>
+            <pc:sldMk cId="3992297113" sldId="275"/>
+            <ac:picMk id="5" creationId="{6E91576D-A001-42CC-FAAE-9319EE21BD0A}"/>
           </ac:picMkLst>
         </pc:picChg>
       </pc:sldChg>
@@ -597,7 +690,7 @@
           <a:p>
             <a:fld id="{1C4BEB1E-4C7A-4CCA-99B1-324C18C730E6}" type="datetimeFigureOut">
               <a:rPr lang="en-US" smtClean="0"/>
-              <a:t>7/14/2025</a:t>
+              <a:t>7/27/2025</a:t>
             </a:fld>
             <a:endParaRPr lang="en-US"/>
           </a:p>
@@ -767,7 +860,7 @@
           <a:p>
             <a:fld id="{1C4BEB1E-4C7A-4CCA-99B1-324C18C730E6}" type="datetimeFigureOut">
               <a:rPr lang="en-US" smtClean="0"/>
-              <a:t>7/14/2025</a:t>
+              <a:t>7/27/2025</a:t>
             </a:fld>
             <a:endParaRPr lang="en-US"/>
           </a:p>
@@ -947,7 +1040,7 @@
           <a:p>
             <a:fld id="{1C4BEB1E-4C7A-4CCA-99B1-324C18C730E6}" type="datetimeFigureOut">
               <a:rPr lang="en-US" smtClean="0"/>
-              <a:t>7/14/2025</a:t>
+              <a:t>7/27/2025</a:t>
             </a:fld>
             <a:endParaRPr lang="en-US"/>
           </a:p>
@@ -1117,7 +1210,7 @@
           <a:p>
             <a:fld id="{1C4BEB1E-4C7A-4CCA-99B1-324C18C730E6}" type="datetimeFigureOut">
               <a:rPr lang="en-US" smtClean="0"/>
-              <a:t>7/14/2025</a:t>
+              <a:t>7/27/2025</a:t>
             </a:fld>
             <a:endParaRPr lang="en-US"/>
           </a:p>
@@ -1361,7 +1454,7 @@
           <a:p>
             <a:fld id="{1C4BEB1E-4C7A-4CCA-99B1-324C18C730E6}" type="datetimeFigureOut">
               <a:rPr lang="en-US" smtClean="0"/>
-              <a:t>7/14/2025</a:t>
+              <a:t>7/27/2025</a:t>
             </a:fld>
             <a:endParaRPr lang="en-US"/>
           </a:p>
@@ -1593,7 +1686,7 @@
           <a:p>
             <a:fld id="{1C4BEB1E-4C7A-4CCA-99B1-324C18C730E6}" type="datetimeFigureOut">
               <a:rPr lang="en-US" smtClean="0"/>
-              <a:t>7/14/2025</a:t>
+              <a:t>7/27/2025</a:t>
             </a:fld>
             <a:endParaRPr lang="en-US"/>
           </a:p>
@@ -1960,7 +2053,7 @@
           <a:p>
             <a:fld id="{1C4BEB1E-4C7A-4CCA-99B1-324C18C730E6}" type="datetimeFigureOut">
               <a:rPr lang="en-US" smtClean="0"/>
-              <a:t>7/14/2025</a:t>
+              <a:t>7/27/2025</a:t>
             </a:fld>
             <a:endParaRPr lang="en-US"/>
           </a:p>
@@ -2078,7 +2171,7 @@
           <a:p>
             <a:fld id="{1C4BEB1E-4C7A-4CCA-99B1-324C18C730E6}" type="datetimeFigureOut">
               <a:rPr lang="en-US" smtClean="0"/>
-              <a:t>7/14/2025</a:t>
+              <a:t>7/27/2025</a:t>
             </a:fld>
             <a:endParaRPr lang="en-US"/>
           </a:p>
@@ -2173,7 +2266,7 @@
           <a:p>
             <a:fld id="{1C4BEB1E-4C7A-4CCA-99B1-324C18C730E6}" type="datetimeFigureOut">
               <a:rPr lang="en-US" smtClean="0"/>
-              <a:t>7/14/2025</a:t>
+              <a:t>7/27/2025</a:t>
             </a:fld>
             <a:endParaRPr lang="en-US"/>
           </a:p>
@@ -2450,7 +2543,7 @@
           <a:p>
             <a:fld id="{1C4BEB1E-4C7A-4CCA-99B1-324C18C730E6}" type="datetimeFigureOut">
               <a:rPr lang="en-US" smtClean="0"/>
-              <a:t>7/14/2025</a:t>
+              <a:t>7/27/2025</a:t>
             </a:fld>
             <a:endParaRPr lang="en-US"/>
           </a:p>
@@ -2707,7 +2800,7 @@
           <a:p>
             <a:fld id="{1C4BEB1E-4C7A-4CCA-99B1-324C18C730E6}" type="datetimeFigureOut">
               <a:rPr lang="en-US" smtClean="0"/>
-              <a:t>7/14/2025</a:t>
+              <a:t>7/27/2025</a:t>
             </a:fld>
             <a:endParaRPr lang="en-US"/>
           </a:p>
@@ -2920,7 +3013,7 @@
           <a:p>
             <a:fld id="{1C4BEB1E-4C7A-4CCA-99B1-324C18C730E6}" type="datetimeFigureOut">
               <a:rPr lang="en-US" smtClean="0"/>
-              <a:t>7/14/2025</a:t>
+              <a:t>7/27/2025</a:t>
             </a:fld>
             <a:endParaRPr lang="en-US"/>
           </a:p>
@@ -3341,7 +3434,20 @@
         </p:nvPicPr>
         <p:blipFill>
           <a:blip r:embed="rId2">
+            <a:biLevel thresh="75000"/>
             <a:extLst>
+              <a:ext uri="{BEBA8EAE-BF5A-486C-A8C5-ECC9F3942E4B}">
+                <a14:imgProps xmlns:a14="http://schemas.microsoft.com/office/drawing/2010/main">
+                  <a14:imgLayer r:embed="rId3">
+                    <a14:imgEffect>
+                      <a14:sharpenSoften amount="50000"/>
+                    </a14:imgEffect>
+                    <a14:imgEffect>
+                      <a14:brightnessContrast bright="40000" contrast="40000"/>
+                    </a14:imgEffect>
+                  </a14:imgLayer>
+                </a14:imgProps>
+              </a:ext>
               <a:ext uri="{28A0092B-C50C-407E-A947-70E740481C1C}">
                 <a14:useLocalDpi xmlns:a14="http://schemas.microsoft.com/office/drawing/2010/main" val="0"/>
               </a:ext>
@@ -3353,7 +3459,7 @@
         </p:blipFill>
         <p:spPr>
           <a:xfrm>
-            <a:off x="454589" y="767479"/>
+            <a:off x="454589" y="825354"/>
             <a:ext cx="6863219" cy="5250363"/>
           </a:xfrm>
           <a:prstGeom prst="rect">
@@ -3376,8 +3482,21 @@
           <p:nvPr/>
         </p:nvPicPr>
         <p:blipFill>
-          <a:blip r:embed="rId3">
+          <a:blip r:embed="rId4">
+            <a:biLevel thresh="75000"/>
             <a:extLst>
+              <a:ext uri="{BEBA8EAE-BF5A-486C-A8C5-ECC9F3942E4B}">
+                <a14:imgProps xmlns:a14="http://schemas.microsoft.com/office/drawing/2010/main">
+                  <a14:imgLayer r:embed="rId5">
+                    <a14:imgEffect>
+                      <a14:sharpenSoften amount="50000"/>
+                    </a14:imgEffect>
+                    <a14:imgEffect>
+                      <a14:brightnessContrast bright="40000" contrast="40000"/>
+                    </a14:imgEffect>
+                  </a14:imgLayer>
+                </a14:imgProps>
+              </a:ext>
               <a:ext uri="{28A0092B-C50C-407E-A947-70E740481C1C}">
                 <a14:useLocalDpi xmlns:a14="http://schemas.microsoft.com/office/drawing/2010/main" val="0"/>
               </a:ext>
@@ -3443,7 +3562,20 @@
         </p:nvPicPr>
         <p:blipFill>
           <a:blip r:embed="rId2">
+            <a:biLevel thresh="75000"/>
             <a:extLst>
+              <a:ext uri="{BEBA8EAE-BF5A-486C-A8C5-ECC9F3942E4B}">
+                <a14:imgProps xmlns:a14="http://schemas.microsoft.com/office/drawing/2010/main">
+                  <a14:imgLayer r:embed="rId3">
+                    <a14:imgEffect>
+                      <a14:sharpenSoften amount="50000"/>
+                    </a14:imgEffect>
+                    <a14:imgEffect>
+                      <a14:brightnessContrast bright="40000" contrast="40000"/>
+                    </a14:imgEffect>
+                  </a14:imgLayer>
+                </a14:imgProps>
+              </a:ext>
               <a:ext uri="{28A0092B-C50C-407E-A947-70E740481C1C}">
                 <a14:useLocalDpi xmlns:a14="http://schemas.microsoft.com/office/drawing/2010/main" val="0"/>
               </a:ext>
@@ -3455,7 +3587,7 @@
         </p:blipFill>
         <p:spPr>
           <a:xfrm>
-            <a:off x="3886200" y="715029"/>
+            <a:off x="3886200" y="1247464"/>
             <a:ext cx="3810000" cy="7781925"/>
           </a:xfrm>
           <a:prstGeom prst="rect">
@@ -3465,10 +3597,10 @@
       </p:pic>
       <p:pic>
         <p:nvPicPr>
-          <p:cNvPr id="5" name="Picture 4" descr="A screenshot of a game&#10;&#10;AI-generated content may be incorrect.">
+          <p:cNvPr id="4" name="Picture 3" descr="A screenshot of a game&#10;&#10;AI-generated content may be incorrect.">
             <a:extLst>
               <a:ext uri="{FF2B5EF4-FFF2-40B4-BE49-F238E27FC236}">
-                <a16:creationId xmlns:a16="http://schemas.microsoft.com/office/drawing/2014/main" id="{6E91576D-A001-42CC-FAAE-9319EE21BD0A}"/>
+                <a16:creationId xmlns:a16="http://schemas.microsoft.com/office/drawing/2014/main" id="{733B8E86-7446-5332-023C-72FF8F909E1E}"/>
               </a:ext>
             </a:extLst>
           </p:cNvPr>
@@ -3478,8 +3610,21 @@
           <p:nvPr/>
         </p:nvPicPr>
         <p:blipFill>
-          <a:blip r:embed="rId3">
+          <a:blip r:embed="rId4">
+            <a:biLevel thresh="75000"/>
             <a:extLst>
+              <a:ext uri="{BEBA8EAE-BF5A-486C-A8C5-ECC9F3942E4B}">
+                <a14:imgProps xmlns:a14="http://schemas.microsoft.com/office/drawing/2010/main">
+                  <a14:imgLayer r:embed="rId5">
+                    <a14:imgEffect>
+                      <a14:sharpenSoften amount="50000"/>
+                    </a14:imgEffect>
+                    <a14:imgEffect>
+                      <a14:brightnessContrast bright="40000" contrast="40000"/>
+                    </a14:imgEffect>
+                  </a14:imgLayer>
+                </a14:imgProps>
+              </a:ext>
               <a:ext uri="{28A0092B-C50C-407E-A947-70E740481C1C}">
                 <a14:useLocalDpi xmlns:a14="http://schemas.microsoft.com/office/drawing/2010/main" val="0"/>
               </a:ext>
@@ -3491,8 +3636,8 @@
         </p:blipFill>
         <p:spPr>
           <a:xfrm>
-            <a:off x="76200" y="715029"/>
-            <a:ext cx="3810000" cy="6715125"/>
+            <a:off x="76200" y="1247464"/>
+            <a:ext cx="3810000" cy="4714875"/>
           </a:xfrm>
           <a:prstGeom prst="rect">
             <a:avLst/>
@@ -3513,6 +3658,262 @@
 </file>
 
 <file path=ppt/slides/slide3.xml><?xml version="1.0" encoding="utf-8"?>
+<p:sld xmlns:a="http://schemas.openxmlformats.org/drawingml/2006/main" xmlns:r="http://schemas.openxmlformats.org/officeDocument/2006/relationships" xmlns:p="http://schemas.openxmlformats.org/presentationml/2006/main">
+  <p:cSld>
+    <p:spTree>
+      <p:nvGrpSpPr>
+        <p:cNvPr id="1" name=""/>
+        <p:cNvGrpSpPr/>
+        <p:nvPr/>
+      </p:nvGrpSpPr>
+      <p:grpSpPr>
+        <a:xfrm>
+          <a:off x="0" y="0"/>
+          <a:ext cx="0" cy="0"/>
+          <a:chOff x="0" y="0"/>
+          <a:chExt cx="0" cy="0"/>
+        </a:xfrm>
+      </p:grpSpPr>
+      <p:pic>
+        <p:nvPicPr>
+          <p:cNvPr id="3" name="Picture 2" descr="A screenshot of a game&#10;&#10;AI-generated content may be incorrect.">
+            <a:extLst>
+              <a:ext uri="{FF2B5EF4-FFF2-40B4-BE49-F238E27FC236}">
+                <a16:creationId xmlns:a16="http://schemas.microsoft.com/office/drawing/2014/main" id="{91AC78E9-A3D5-3A97-D22B-1C99083F134A}"/>
+              </a:ext>
+            </a:extLst>
+          </p:cNvPr>
+          <p:cNvPicPr>
+            <a:picLocks noChangeAspect="1"/>
+          </p:cNvPicPr>
+          <p:nvPr/>
+        </p:nvPicPr>
+        <p:blipFill>
+          <a:blip r:embed="rId2">
+            <a:biLevel thresh="75000"/>
+            <a:extLst>
+              <a:ext uri="{BEBA8EAE-BF5A-486C-A8C5-ECC9F3942E4B}">
+                <a14:imgProps xmlns:a14="http://schemas.microsoft.com/office/drawing/2010/main">
+                  <a14:imgLayer r:embed="rId3">
+                    <a14:imgEffect>
+                      <a14:sharpenSoften amount="50000"/>
+                    </a14:imgEffect>
+                    <a14:imgEffect>
+                      <a14:brightnessContrast bright="40000" contrast="40000"/>
+                    </a14:imgEffect>
+                  </a14:imgLayer>
+                </a14:imgProps>
+              </a:ext>
+              <a:ext uri="{28A0092B-C50C-407E-A947-70E740481C1C}">
+                <a14:useLocalDpi xmlns:a14="http://schemas.microsoft.com/office/drawing/2010/main" val="0"/>
+              </a:ext>
+            </a:extLst>
+          </a:blip>
+          <a:stretch>
+            <a:fillRect/>
+          </a:stretch>
+        </p:blipFill>
+        <p:spPr>
+          <a:xfrm>
+            <a:off x="76200" y="952344"/>
+            <a:ext cx="7620000" cy="5010150"/>
+          </a:xfrm>
+          <a:prstGeom prst="rect">
+            <a:avLst/>
+          </a:prstGeom>
+        </p:spPr>
+      </p:pic>
+      <p:pic>
+        <p:nvPicPr>
+          <p:cNvPr id="7" name="Picture 6" descr="A close-up of a card&#10;&#10;AI-generated content may be incorrect.">
+            <a:extLst>
+              <a:ext uri="{FF2B5EF4-FFF2-40B4-BE49-F238E27FC236}">
+                <a16:creationId xmlns:a16="http://schemas.microsoft.com/office/drawing/2014/main" id="{8F7240C5-D356-1198-939E-F91B4DB0ACE6}"/>
+              </a:ext>
+            </a:extLst>
+          </p:cNvPr>
+          <p:cNvPicPr>
+            <a:picLocks noChangeAspect="1"/>
+          </p:cNvPicPr>
+          <p:nvPr/>
+        </p:nvPicPr>
+        <p:blipFill>
+          <a:blip r:embed="rId4">
+            <a:biLevel thresh="75000"/>
+            <a:extLst>
+              <a:ext uri="{BEBA8EAE-BF5A-486C-A8C5-ECC9F3942E4B}">
+                <a14:imgProps xmlns:a14="http://schemas.microsoft.com/office/drawing/2010/main">
+                  <a14:imgLayer r:embed="rId5">
+                    <a14:imgEffect>
+                      <a14:sharpenSoften amount="50000"/>
+                    </a14:imgEffect>
+                    <a14:imgEffect>
+                      <a14:brightnessContrast bright="40000" contrast="40000"/>
+                    </a14:imgEffect>
+                  </a14:imgLayer>
+                </a14:imgProps>
+              </a:ext>
+              <a:ext uri="{28A0092B-C50C-407E-A947-70E740481C1C}">
+                <a14:useLocalDpi xmlns:a14="http://schemas.microsoft.com/office/drawing/2010/main" val="0"/>
+              </a:ext>
+            </a:extLst>
+          </a:blip>
+          <a:stretch>
+            <a:fillRect/>
+          </a:stretch>
+        </p:blipFill>
+        <p:spPr>
+          <a:xfrm>
+            <a:off x="76200" y="5899412"/>
+            <a:ext cx="7620000" cy="3952875"/>
+          </a:xfrm>
+          <a:prstGeom prst="rect">
+            <a:avLst/>
+          </a:prstGeom>
+        </p:spPr>
+      </p:pic>
+    </p:spTree>
+    <p:extLst>
+      <p:ext uri="{BB962C8B-B14F-4D97-AF65-F5344CB8AC3E}">
+        <p14:creationId xmlns:p14="http://schemas.microsoft.com/office/powerpoint/2010/main" val="1481890868"/>
+      </p:ext>
+    </p:extLst>
+  </p:cSld>
+  <p:clrMapOvr>
+    <a:masterClrMapping/>
+  </p:clrMapOvr>
+</p:sld>
+</file>
+
+<file path=ppt/slides/slide4.xml><?xml version="1.0" encoding="utf-8"?>
+<p:sld xmlns:a="http://schemas.openxmlformats.org/drawingml/2006/main" xmlns:r="http://schemas.openxmlformats.org/officeDocument/2006/relationships" xmlns:p="http://schemas.openxmlformats.org/presentationml/2006/main">
+  <p:cSld>
+    <p:spTree>
+      <p:nvGrpSpPr>
+        <p:cNvPr id="1" name=""/>
+        <p:cNvGrpSpPr/>
+        <p:nvPr/>
+      </p:nvGrpSpPr>
+      <p:grpSpPr>
+        <a:xfrm>
+          <a:off x="0" y="0"/>
+          <a:ext cx="0" cy="0"/>
+          <a:chOff x="0" y="0"/>
+          <a:chExt cx="0" cy="0"/>
+        </a:xfrm>
+      </p:grpSpPr>
+      <p:pic>
+        <p:nvPicPr>
+          <p:cNvPr id="5" name="Picture 4" descr="A screenshot of a game&#10;&#10;AI-generated content may be incorrect.">
+            <a:extLst>
+              <a:ext uri="{FF2B5EF4-FFF2-40B4-BE49-F238E27FC236}">
+                <a16:creationId xmlns:a16="http://schemas.microsoft.com/office/drawing/2014/main" id="{6E91576D-A001-42CC-FAAE-9319EE21BD0A}"/>
+              </a:ext>
+            </a:extLst>
+          </p:cNvPr>
+          <p:cNvPicPr>
+            <a:picLocks noChangeAspect="1"/>
+          </p:cNvPicPr>
+          <p:nvPr/>
+        </p:nvPicPr>
+        <p:blipFill>
+          <a:blip r:embed="rId2">
+            <a:biLevel thresh="75000"/>
+            <a:extLst>
+              <a:ext uri="{BEBA8EAE-BF5A-486C-A8C5-ECC9F3942E4B}">
+                <a14:imgProps xmlns:a14="http://schemas.microsoft.com/office/drawing/2010/main">
+                  <a14:imgLayer r:embed="rId3">
+                    <a14:imgEffect>
+                      <a14:sharpenSoften amount="50000"/>
+                    </a14:imgEffect>
+                    <a14:imgEffect>
+                      <a14:brightnessContrast bright="40000" contrast="40000"/>
+                    </a14:imgEffect>
+                  </a14:imgLayer>
+                </a14:imgProps>
+              </a:ext>
+              <a:ext uri="{28A0092B-C50C-407E-A947-70E740481C1C}">
+                <a14:useLocalDpi xmlns:a14="http://schemas.microsoft.com/office/drawing/2010/main" val="0"/>
+              </a:ext>
+            </a:extLst>
+          </a:blip>
+          <a:stretch>
+            <a:fillRect/>
+          </a:stretch>
+        </p:blipFill>
+        <p:spPr>
+          <a:xfrm>
+            <a:off x="76200" y="2046117"/>
+            <a:ext cx="3810000" cy="6715125"/>
+          </a:xfrm>
+          <a:prstGeom prst="rect">
+            <a:avLst/>
+          </a:prstGeom>
+        </p:spPr>
+      </p:pic>
+      <p:pic>
+        <p:nvPicPr>
+          <p:cNvPr id="2" name="Picture 1" descr="A screenshot of a game&#10;&#10;AI-generated content may be incorrect.">
+            <a:extLst>
+              <a:ext uri="{FF2B5EF4-FFF2-40B4-BE49-F238E27FC236}">
+                <a16:creationId xmlns:a16="http://schemas.microsoft.com/office/drawing/2014/main" id="{4B5CF763-5573-D89F-CCD4-E6AEBE44F4EA}"/>
+              </a:ext>
+            </a:extLst>
+          </p:cNvPr>
+          <p:cNvPicPr>
+            <a:picLocks noChangeAspect="1"/>
+          </p:cNvPicPr>
+          <p:nvPr/>
+        </p:nvPicPr>
+        <p:blipFill>
+          <a:blip r:embed="rId4">
+            <a:biLevel thresh="75000"/>
+            <a:extLst>
+              <a:ext uri="{BEBA8EAE-BF5A-486C-A8C5-ECC9F3942E4B}">
+                <a14:imgProps xmlns:a14="http://schemas.microsoft.com/office/drawing/2010/main">
+                  <a14:imgLayer r:embed="rId5">
+                    <a14:imgEffect>
+                      <a14:sharpenSoften amount="50000"/>
+                    </a14:imgEffect>
+                    <a14:imgEffect>
+                      <a14:brightnessContrast bright="40000" contrast="40000"/>
+                    </a14:imgEffect>
+                  </a14:imgLayer>
+                </a14:imgProps>
+              </a:ext>
+              <a:ext uri="{28A0092B-C50C-407E-A947-70E740481C1C}">
+                <a14:useLocalDpi xmlns:a14="http://schemas.microsoft.com/office/drawing/2010/main" val="0"/>
+              </a:ext>
+            </a:extLst>
+          </a:blip>
+          <a:stretch>
+            <a:fillRect/>
+          </a:stretch>
+        </p:blipFill>
+        <p:spPr>
+          <a:xfrm>
+            <a:off x="3886200" y="2046117"/>
+            <a:ext cx="3810000" cy="5943600"/>
+          </a:xfrm>
+          <a:prstGeom prst="rect">
+            <a:avLst/>
+          </a:prstGeom>
+        </p:spPr>
+      </p:pic>
+    </p:spTree>
+    <p:extLst>
+      <p:ext uri="{BB962C8B-B14F-4D97-AF65-F5344CB8AC3E}">
+        <p14:creationId xmlns:p14="http://schemas.microsoft.com/office/powerpoint/2010/main" val="3992297113"/>
+      </p:ext>
+    </p:extLst>
+  </p:cSld>
+  <p:clrMapOvr>
+    <a:masterClrMapping/>
+  </p:clrMapOvr>
+</p:sld>
+</file>
+
+<file path=ppt/slides/slide5.xml><?xml version="1.0" encoding="utf-8"?>
 <p:sld xmlns:a="http://schemas.openxmlformats.org/drawingml/2006/main" xmlns:r="http://schemas.openxmlformats.org/officeDocument/2006/relationships" xmlns:p="http://schemas.openxmlformats.org/presentationml/2006/main">
   <p:cSld>
     <p:spTree>
@@ -3765,6 +4166,78 @@
           </p:spPr>
         </p:pic>
       </p:grpSp>
+      <p:pic>
+        <p:nvPicPr>
+          <p:cNvPr id="11" name="Picture 10">
+            <a:extLst>
+              <a:ext uri="{FF2B5EF4-FFF2-40B4-BE49-F238E27FC236}">
+                <a16:creationId xmlns:a16="http://schemas.microsoft.com/office/drawing/2014/main" id="{1074A41F-3010-1D11-5AC9-95519D94BD92}"/>
+              </a:ext>
+            </a:extLst>
+          </p:cNvPr>
+          <p:cNvPicPr>
+            <a:picLocks noChangeAspect="1"/>
+          </p:cNvPicPr>
+          <p:nvPr/>
+        </p:nvPicPr>
+        <p:blipFill>
+          <a:blip r:embed="rId4"/>
+          <a:stretch>
+            <a:fillRect/>
+          </a:stretch>
+        </p:blipFill>
+        <p:spPr>
+          <a:xfrm>
+            <a:off x="929384" y="6108011"/>
+            <a:ext cx="2956816" cy="2615411"/>
+          </a:xfrm>
+          <a:prstGeom prst="rect">
+            <a:avLst/>
+          </a:prstGeom>
+          <a:ln>
+            <a:noFill/>
+          </a:ln>
+          <a:effectLst>
+            <a:softEdge rad="112500"/>
+          </a:effectLst>
+        </p:spPr>
+      </p:pic>
+      <p:pic>
+        <p:nvPicPr>
+          <p:cNvPr id="12" name="Picture 11">
+            <a:extLst>
+              <a:ext uri="{FF2B5EF4-FFF2-40B4-BE49-F238E27FC236}">
+                <a16:creationId xmlns:a16="http://schemas.microsoft.com/office/drawing/2014/main" id="{15294488-E48F-F433-D3FB-734BDAE59C9C}"/>
+              </a:ext>
+            </a:extLst>
+          </p:cNvPr>
+          <p:cNvPicPr>
+            <a:picLocks noChangeAspect="1"/>
+          </p:cNvPicPr>
+          <p:nvPr/>
+        </p:nvPicPr>
+        <p:blipFill>
+          <a:blip r:embed="rId4"/>
+          <a:stretch>
+            <a:fillRect/>
+          </a:stretch>
+        </p:blipFill>
+        <p:spPr>
+          <a:xfrm flipH="1">
+            <a:off x="3886200" y="6108012"/>
+            <a:ext cx="2921736" cy="2615411"/>
+          </a:xfrm>
+          <a:prstGeom prst="rect">
+            <a:avLst/>
+          </a:prstGeom>
+          <a:ln>
+            <a:noFill/>
+          </a:ln>
+          <a:effectLst>
+            <a:softEdge rad="112500"/>
+          </a:effectLst>
+        </p:spPr>
+      </p:pic>
     </p:spTree>
     <p:extLst>
       <p:ext uri="{BB962C8B-B14F-4D97-AF65-F5344CB8AC3E}">

</xml_diff>